<commit_message>
Update Slide 10 with official GitHub repository link
</commit_message>
<xml_diff>
--- a/Amazon_Reviews_BigData_Presentation.pptx
+++ b/Amazon_Reviews_BigData_Presentation.pptx
@@ -3279,7 +3279,7 @@
               </a:defRPr>
             </a:pPr>
             <a:r>
-              <a:t>• Team Member Name(s):  [Your Name / Team Members]</a:t>
+              <a:t>• Team Member Name(s):  Mathangi Avinash (aavi4502-pixel)</a:t>
             </a:r>
             <a:br/>
             <a:r>
@@ -3573,7 +3573,7 @@
                   <a:srgbClr val="212529"/>
                 </a:solidFill>
               </a:rPr>
-              <a:t>https://github.com/[username]/ecommerce-review-spam-detection-bigdata (Upload repository for code, Scala scripts, and Docker configs).</a:t>
+              <a:t>https://github.com/aavi4502-pixel/ecommerce-review-spam-detection-bigdata (Repository containing PPT, Report, Scala, MapReduce, and Spark pipelines).</a:t>
             </a:r>
           </a:p>
           <a:p>

</xml_diff>